<commit_message>
Rebuild site: Lecture 1 and 2 round 2 revisions, native diagrams, Vietnamese wording
</commit_message>
<xml_diff>
--- a/en/files/slides/Session_3_EN.pptx
+++ b/en/files/slides/Session_3_EN.pptx
@@ -1929,7 +1929,7 @@
           <a:p>
             <a:r>
               <a:rPr lang="en-US" sz="1400" b="0" dirty="0"/>
-              <a:t>Run it as three poll questions (Zoom or Teams poll, or a form). Show the results, then the answer.</a:t>
+              <a:t>Run it as three poll questions (Zoom or Teams poll). Show the results, then the answer.</a:t>
             </a:r>
           </a:p>
           <a:p>
@@ -9204,12 +9204,12 @@
           </a:ln>
         </p:spPr>
         <p:txBody>
-          <a:bodyPr wrap="square" lIns="110000" tIns="91440" rIns="110000" bIns="91440" rtlCol="0" anchor="t">
+          <a:bodyPr wrap="square" lIns="110000" tIns="91440" rIns="110000" bIns="91440" rtlCol="0" anchor="ctr">
             <a:normAutofit/>
           </a:bodyPr>
           <a:lstStyle/>
           <a:p>
-            <a:pPr marL="0" indent="0" algn="l">
+            <a:pPr marL="0" indent="0" algn="ctr">
               <a:lnSpc>
                 <a:spcPct val="104000"/>
               </a:lnSpc>
@@ -9298,12 +9298,12 @@
           </a:ln>
         </p:spPr>
         <p:txBody>
-          <a:bodyPr wrap="square" lIns="110000" tIns="91440" rIns="110000" bIns="91440" rtlCol="0" anchor="t">
+          <a:bodyPr wrap="square" lIns="110000" tIns="91440" rIns="110000" bIns="91440" rtlCol="0" anchor="ctr">
             <a:normAutofit/>
           </a:bodyPr>
           <a:lstStyle/>
           <a:p>
-            <a:pPr marL="0" indent="0" algn="l">
+            <a:pPr marL="0" indent="0" algn="ctr">
               <a:lnSpc>
                 <a:spcPct val="104000"/>
               </a:lnSpc>
@@ -9392,12 +9392,12 @@
           </a:ln>
         </p:spPr>
         <p:txBody>
-          <a:bodyPr wrap="square" lIns="110000" tIns="91440" rIns="110000" bIns="91440" rtlCol="0" anchor="t">
+          <a:bodyPr wrap="square" lIns="110000" tIns="91440" rIns="110000" bIns="91440" rtlCol="0" anchor="ctr">
             <a:normAutofit/>
           </a:bodyPr>
           <a:lstStyle/>
           <a:p>
-            <a:pPr marL="0" indent="0" algn="l">
+            <a:pPr marL="0" indent="0" algn="ctr">
               <a:lnSpc>
                 <a:spcPct val="104000"/>
               </a:lnSpc>
@@ -9486,12 +9486,12 @@
           </a:ln>
         </p:spPr>
         <p:txBody>
-          <a:bodyPr wrap="square" lIns="110000" tIns="91440" rIns="110000" bIns="91440" rtlCol="0" anchor="t">
+          <a:bodyPr wrap="square" lIns="110000" tIns="91440" rIns="110000" bIns="91440" rtlCol="0" anchor="ctr">
             <a:normAutofit/>
           </a:bodyPr>
           <a:lstStyle/>
           <a:p>
-            <a:pPr marL="0" indent="0" algn="l">
+            <a:pPr marL="0" indent="0" algn="ctr">
               <a:lnSpc>
                 <a:spcPct val="104000"/>
               </a:lnSpc>
@@ -9580,12 +9580,12 @@
           </a:ln>
         </p:spPr>
         <p:txBody>
-          <a:bodyPr wrap="square" lIns="110000" tIns="91440" rIns="110000" bIns="91440" rtlCol="0" anchor="t">
+          <a:bodyPr wrap="square" lIns="110000" tIns="91440" rIns="110000" bIns="91440" rtlCol="0" anchor="ctr">
             <a:normAutofit/>
           </a:bodyPr>
           <a:lstStyle/>
           <a:p>
-            <a:pPr marL="0" indent="0" algn="l">
+            <a:pPr marL="0" indent="0" algn="ctr">
               <a:lnSpc>
                 <a:spcPct val="104000"/>
               </a:lnSpc>
@@ -10239,12 +10239,12 @@
           </a:ln>
         </p:spPr>
         <p:txBody>
-          <a:bodyPr wrap="square" lIns="110000" tIns="91440" rIns="110000" bIns="91440" rtlCol="0" anchor="t">
+          <a:bodyPr wrap="square" lIns="110000" tIns="91440" rIns="110000" bIns="91440" rtlCol="0" anchor="ctr">
             <a:normAutofit/>
           </a:bodyPr>
           <a:lstStyle/>
           <a:p>
-            <a:pPr marL="0" indent="0" algn="l">
+            <a:pPr marL="0" indent="0" algn="ctr">
               <a:lnSpc>
                 <a:spcPct val="104000"/>
               </a:lnSpc>
@@ -10333,12 +10333,12 @@
           </a:ln>
         </p:spPr>
         <p:txBody>
-          <a:bodyPr wrap="square" lIns="110000" tIns="91440" rIns="110000" bIns="91440" rtlCol="0" anchor="t">
+          <a:bodyPr wrap="square" lIns="110000" tIns="91440" rIns="110000" bIns="91440" rtlCol="0" anchor="ctr">
             <a:normAutofit/>
           </a:bodyPr>
           <a:lstStyle/>
           <a:p>
-            <a:pPr marL="0" indent="0" algn="l">
+            <a:pPr marL="0" indent="0" algn="ctr">
               <a:lnSpc>
                 <a:spcPct val="104000"/>
               </a:lnSpc>
@@ -10427,12 +10427,12 @@
           </a:ln>
         </p:spPr>
         <p:txBody>
-          <a:bodyPr wrap="square" lIns="110000" tIns="91440" rIns="110000" bIns="91440" rtlCol="0" anchor="t">
+          <a:bodyPr wrap="square" lIns="110000" tIns="91440" rIns="110000" bIns="91440" rtlCol="0" anchor="ctr">
             <a:normAutofit/>
           </a:bodyPr>
           <a:lstStyle/>
           <a:p>
-            <a:pPr marL="0" indent="0" algn="l">
+            <a:pPr marL="0" indent="0" algn="ctr">
               <a:lnSpc>
                 <a:spcPct val="104000"/>
               </a:lnSpc>
@@ -10521,12 +10521,12 @@
           </a:ln>
         </p:spPr>
         <p:txBody>
-          <a:bodyPr wrap="square" lIns="110000" tIns="91440" rIns="110000" bIns="91440" rtlCol="0" anchor="t">
+          <a:bodyPr wrap="square" lIns="110000" tIns="91440" rIns="110000" bIns="91440" rtlCol="0" anchor="ctr">
             <a:normAutofit/>
           </a:bodyPr>
           <a:lstStyle/>
           <a:p>
-            <a:pPr marL="0" indent="0" algn="l">
+            <a:pPr marL="0" indent="0" algn="ctr">
               <a:lnSpc>
                 <a:spcPct val="104000"/>
               </a:lnSpc>
@@ -11219,12 +11219,12 @@
           </a:ln>
         </p:spPr>
         <p:txBody>
-          <a:bodyPr wrap="square" lIns="110000" tIns="91440" rIns="110000" bIns="91440" rtlCol="0" anchor="t">
+          <a:bodyPr wrap="square" lIns="110000" tIns="91440" rIns="110000" bIns="91440" rtlCol="0" anchor="ctr">
             <a:normAutofit/>
           </a:bodyPr>
           <a:lstStyle/>
           <a:p>
-            <a:pPr marL="0" indent="0" algn="l">
+            <a:pPr marL="0" indent="0" algn="ctr">
               <a:lnSpc>
                 <a:spcPct val="104000"/>
               </a:lnSpc>
@@ -11313,12 +11313,12 @@
           </a:ln>
         </p:spPr>
         <p:txBody>
-          <a:bodyPr wrap="square" lIns="110000" tIns="91440" rIns="110000" bIns="91440" rtlCol="0" anchor="t">
+          <a:bodyPr wrap="square" lIns="110000" tIns="91440" rIns="110000" bIns="91440" rtlCol="0" anchor="ctr">
             <a:normAutofit/>
           </a:bodyPr>
           <a:lstStyle/>
           <a:p>
-            <a:pPr marL="0" indent="0" algn="l">
+            <a:pPr marL="0" indent="0" algn="ctr">
               <a:lnSpc>
                 <a:spcPct val="104000"/>
               </a:lnSpc>
@@ -11407,12 +11407,12 @@
           </a:ln>
         </p:spPr>
         <p:txBody>
-          <a:bodyPr wrap="square" lIns="110000" tIns="91440" rIns="110000" bIns="91440" rtlCol="0" anchor="t">
+          <a:bodyPr wrap="square" lIns="110000" tIns="91440" rIns="110000" bIns="91440" rtlCol="0" anchor="ctr">
             <a:normAutofit/>
           </a:bodyPr>
           <a:lstStyle/>
           <a:p>
-            <a:pPr marL="0" indent="0" algn="l">
+            <a:pPr marL="0" indent="0" algn="ctr">
               <a:lnSpc>
                 <a:spcPct val="104000"/>
               </a:lnSpc>
@@ -11501,12 +11501,12 @@
           </a:ln>
         </p:spPr>
         <p:txBody>
-          <a:bodyPr wrap="square" lIns="110000" tIns="91440" rIns="110000" bIns="91440" rtlCol="0" anchor="t">
+          <a:bodyPr wrap="square" lIns="110000" tIns="91440" rIns="110000" bIns="91440" rtlCol="0" anchor="ctr">
             <a:normAutofit/>
           </a:bodyPr>
           <a:lstStyle/>
           <a:p>
-            <a:pPr marL="0" indent="0" algn="l">
+            <a:pPr marL="0" indent="0" algn="ctr">
               <a:lnSpc>
                 <a:spcPct val="104000"/>
               </a:lnSpc>
@@ -11595,12 +11595,12 @@
           </a:ln>
         </p:spPr>
         <p:txBody>
-          <a:bodyPr wrap="square" lIns="110000" tIns="91440" rIns="110000" bIns="91440" rtlCol="0" anchor="t">
+          <a:bodyPr wrap="square" lIns="110000" tIns="91440" rIns="110000" bIns="91440" rtlCol="0" anchor="ctr">
             <a:normAutofit/>
           </a:bodyPr>
           <a:lstStyle/>
           <a:p>
-            <a:pPr marL="0" indent="0" algn="l">
+            <a:pPr marL="0" indent="0" algn="ctr">
               <a:lnSpc>
                 <a:spcPct val="104000"/>
               </a:lnSpc>
@@ -12881,12 +12881,12 @@
           </a:ln>
         </p:spPr>
         <p:txBody>
-          <a:bodyPr wrap="square" lIns="137160" tIns="91440" rIns="137160" bIns="91440" rtlCol="0" anchor="t">
+          <a:bodyPr wrap="square" lIns="137160" tIns="91440" rIns="137160" bIns="91440" rtlCol="0" anchor="ctr">
             <a:normAutofit/>
           </a:bodyPr>
           <a:lstStyle/>
           <a:p>
-            <a:pPr marL="0" indent="0" algn="l">
+            <a:pPr marL="0" indent="0" algn="ctr">
               <a:lnSpc>
                 <a:spcPct val="104000"/>
               </a:lnSpc>
@@ -12907,7 +12907,7 @@
             </a:r>
           </a:p>
           <a:p>
-            <a:pPr marL="0" indent="0" algn="l">
+            <a:pPr marL="0" indent="0" algn="ctr">
               <a:lnSpc>
                 <a:spcPct val="104000"/>
               </a:lnSpc>
@@ -12928,7 +12928,7 @@
             </a:r>
           </a:p>
           <a:p>
-            <a:pPr marL="0" indent="0" algn="l">
+            <a:pPr marL="0" indent="0" algn="ctr">
               <a:lnSpc>
                 <a:spcPct val="104000"/>
               </a:lnSpc>
@@ -13015,12 +13015,12 @@
           </a:ln>
         </p:spPr>
         <p:txBody>
-          <a:bodyPr wrap="square" lIns="137160" tIns="91440" rIns="137160" bIns="91440" rtlCol="0" anchor="t">
+          <a:bodyPr wrap="square" lIns="137160" tIns="91440" rIns="137160" bIns="91440" rtlCol="0" anchor="ctr">
             <a:normAutofit/>
           </a:bodyPr>
           <a:lstStyle/>
           <a:p>
-            <a:pPr marL="0" indent="0" algn="l">
+            <a:pPr marL="0" indent="0" algn="ctr">
               <a:lnSpc>
                 <a:spcPct val="104000"/>
               </a:lnSpc>
@@ -13041,7 +13041,7 @@
             </a:r>
           </a:p>
           <a:p>
-            <a:pPr marL="0" indent="0" algn="l">
+            <a:pPr marL="0" indent="0" algn="ctr">
               <a:lnSpc>
                 <a:spcPct val="104000"/>
               </a:lnSpc>
@@ -13062,7 +13062,7 @@
             </a:r>
           </a:p>
           <a:p>
-            <a:pPr marL="0" indent="0" algn="l">
+            <a:pPr marL="0" indent="0" algn="ctr">
               <a:lnSpc>
                 <a:spcPct val="104000"/>
               </a:lnSpc>
@@ -13083,7 +13083,7 @@
             </a:r>
           </a:p>
           <a:p>
-            <a:pPr marL="0" indent="0" algn="l">
+            <a:pPr marL="0" indent="0" algn="ctr">
               <a:lnSpc>
                 <a:spcPct val="104000"/>
               </a:lnSpc>
@@ -13170,12 +13170,12 @@
           </a:ln>
         </p:spPr>
         <p:txBody>
-          <a:bodyPr wrap="square" lIns="137160" tIns="91440" rIns="137160" bIns="91440" rtlCol="0" anchor="t">
+          <a:bodyPr wrap="square" lIns="137160" tIns="91440" rIns="137160" bIns="91440" rtlCol="0" anchor="ctr">
             <a:normAutofit/>
           </a:bodyPr>
           <a:lstStyle/>
           <a:p>
-            <a:pPr marL="0" indent="0" algn="l">
+            <a:pPr marL="0" indent="0" algn="ctr">
               <a:lnSpc>
                 <a:spcPct val="104000"/>
               </a:lnSpc>
@@ -13196,7 +13196,7 @@
             </a:r>
           </a:p>
           <a:p>
-            <a:pPr marL="0" indent="0" algn="l">
+            <a:pPr marL="0" indent="0" algn="ctr">
               <a:lnSpc>
                 <a:spcPct val="104000"/>
               </a:lnSpc>
@@ -13217,7 +13217,7 @@
             </a:r>
           </a:p>
           <a:p>
-            <a:pPr marL="0" indent="0" algn="l">
+            <a:pPr marL="0" indent="0" algn="ctr">
               <a:lnSpc>
                 <a:spcPct val="104000"/>
               </a:lnSpc>
@@ -13238,7 +13238,7 @@
             </a:r>
           </a:p>
           <a:p>
-            <a:pPr marL="0" indent="0" algn="l">
+            <a:pPr marL="0" indent="0" algn="ctr">
               <a:lnSpc>
                 <a:spcPct val="104000"/>
               </a:lnSpc>
@@ -13325,12 +13325,12 @@
           </a:ln>
         </p:spPr>
         <p:txBody>
-          <a:bodyPr wrap="square" lIns="137160" tIns="91440" rIns="137160" bIns="91440" rtlCol="0" anchor="t">
+          <a:bodyPr wrap="square" lIns="137160" tIns="91440" rIns="137160" bIns="91440" rtlCol="0" anchor="ctr">
             <a:normAutofit/>
           </a:bodyPr>
           <a:lstStyle/>
           <a:p>
-            <a:pPr marL="0" indent="0" algn="l">
+            <a:pPr marL="0" indent="0" algn="ctr">
               <a:lnSpc>
                 <a:spcPct val="104000"/>
               </a:lnSpc>
@@ -13351,7 +13351,7 @@
             </a:r>
           </a:p>
           <a:p>
-            <a:pPr marL="0" indent="0" algn="l">
+            <a:pPr marL="0" indent="0" algn="ctr">
               <a:lnSpc>
                 <a:spcPct val="104000"/>
               </a:lnSpc>
@@ -13372,7 +13372,7 @@
             </a:r>
           </a:p>
           <a:p>
-            <a:pPr marL="0" indent="0" algn="l">
+            <a:pPr marL="0" indent="0" algn="ctr">
               <a:lnSpc>
                 <a:spcPct val="104000"/>
               </a:lnSpc>
@@ -13393,7 +13393,7 @@
             </a:r>
           </a:p>
           <a:p>
-            <a:pPr marL="0" indent="0" algn="l">
+            <a:pPr marL="0" indent="0" algn="ctr">
               <a:lnSpc>
                 <a:spcPct val="104000"/>
               </a:lnSpc>
@@ -13857,12 +13857,12 @@
           </a:ln>
         </p:spPr>
         <p:txBody>
-          <a:bodyPr wrap="square" lIns="137160" tIns="91440" rIns="137160" bIns="91440" rtlCol="0" anchor="t">
+          <a:bodyPr wrap="square" lIns="137160" tIns="91440" rIns="137160" bIns="91440" rtlCol="0" anchor="ctr">
             <a:normAutofit/>
           </a:bodyPr>
           <a:lstStyle/>
           <a:p>
-            <a:pPr marL="0" indent="0" algn="l">
+            <a:pPr marL="0" indent="0" algn="ctr">
               <a:buNone/>
             </a:pPr>
             <a:r>
@@ -13877,15 +13877,14 @@
             </a:r>
           </a:p>
           <a:p>
-            <a:pPr marL="274320" indent="-274320" algn="l">
+            <a:pPr marL="0" indent="0" algn="ctr">
               <a:lnSpc>
                 <a:spcPct val="104000"/>
               </a:lnSpc>
               <a:spcBef>
                 <a:spcPts val="300"/>
               </a:spcBef>
-              <a:buFont typeface="Arial"/>
-              <a:buChar char="•"/>
+              <a:buNone/>
             </a:pPr>
             <a:r>
               <a:rPr lang="en-US" sz="1500" dirty="0">
@@ -13899,15 +13898,14 @@
             </a:r>
           </a:p>
           <a:p>
-            <a:pPr marL="274320" indent="-274320" algn="l">
+            <a:pPr marL="0" indent="0" algn="ctr">
               <a:lnSpc>
                 <a:spcPct val="104000"/>
               </a:lnSpc>
               <a:spcBef>
                 <a:spcPts val="300"/>
               </a:spcBef>
-              <a:buFont typeface="Arial"/>
-              <a:buChar char="•"/>
+              <a:buNone/>
             </a:pPr>
             <a:r>
               <a:rPr lang="en-US" sz="1500" dirty="0">
@@ -13921,15 +13919,14 @@
             </a:r>
           </a:p>
           <a:p>
-            <a:pPr marL="274320" indent="-274320" algn="l">
+            <a:pPr marL="0" indent="0" algn="ctr">
               <a:lnSpc>
                 <a:spcPct val="104000"/>
               </a:lnSpc>
               <a:spcBef>
                 <a:spcPts val="300"/>
               </a:spcBef>
-              <a:buFont typeface="Arial"/>
-              <a:buChar char="•"/>
+              <a:buNone/>
             </a:pPr>
             <a:r>
               <a:rPr lang="en-US" sz="1500" dirty="0">
@@ -14262,12 +14259,12 @@
           </a:ln>
         </p:spPr>
         <p:txBody>
-          <a:bodyPr wrap="square" lIns="137160" tIns="91440" rIns="137160" bIns="91440" rtlCol="0" anchor="t">
+          <a:bodyPr wrap="square" lIns="137160" tIns="91440" rIns="137160" bIns="91440" rtlCol="0" anchor="ctr">
             <a:normAutofit/>
           </a:bodyPr>
           <a:lstStyle/>
           <a:p>
-            <a:pPr marL="0" indent="0" algn="l">
+            <a:pPr marL="0" indent="0" algn="ctr">
               <a:lnSpc>
                 <a:spcPct val="104000"/>
               </a:lnSpc>
@@ -14288,7 +14285,7 @@
             </a:r>
           </a:p>
           <a:p>
-            <a:pPr marL="0" indent="0" algn="l">
+            <a:pPr marL="0" indent="0" algn="ctr">
               <a:lnSpc>
                 <a:spcPct val="104000"/>
               </a:lnSpc>
@@ -14309,7 +14306,7 @@
             </a:r>
           </a:p>
           <a:p>
-            <a:pPr marL="0" indent="0" algn="l">
+            <a:pPr marL="0" indent="0" algn="ctr">
               <a:lnSpc>
                 <a:spcPct val="104000"/>
               </a:lnSpc>
@@ -14330,7 +14327,7 @@
             </a:r>
           </a:p>
           <a:p>
-            <a:pPr marL="0" indent="0" algn="l">
+            <a:pPr marL="0" indent="0" algn="ctr">
               <a:lnSpc>
                 <a:spcPct val="104000"/>
               </a:lnSpc>
@@ -14351,7 +14348,7 @@
             </a:r>
           </a:p>
           <a:p>
-            <a:pPr marL="0" indent="0" algn="l">
+            <a:pPr marL="0" indent="0" algn="ctr">
               <a:lnSpc>
                 <a:spcPct val="104000"/>
               </a:lnSpc>
@@ -14372,7 +14369,7 @@
             </a:r>
           </a:p>
           <a:p>
-            <a:pPr marL="0" indent="0" algn="l">
+            <a:pPr marL="0" indent="0" algn="ctr">
               <a:lnSpc>
                 <a:spcPct val="104000"/>
               </a:lnSpc>
@@ -14459,12 +14456,12 @@
           </a:ln>
         </p:spPr>
         <p:txBody>
-          <a:bodyPr wrap="square" lIns="137160" tIns="91440" rIns="137160" bIns="91440" rtlCol="0" anchor="t">
+          <a:bodyPr wrap="square" lIns="137160" tIns="91440" rIns="137160" bIns="91440" rtlCol="0" anchor="ctr">
             <a:normAutofit/>
           </a:bodyPr>
           <a:lstStyle/>
           <a:p>
-            <a:pPr marL="0" indent="0" algn="l">
+            <a:pPr marL="0" indent="0" algn="ctr">
               <a:lnSpc>
                 <a:spcPct val="104000"/>
               </a:lnSpc>
@@ -14485,7 +14482,7 @@
             </a:r>
           </a:p>
           <a:p>
-            <a:pPr marL="0" indent="0" algn="l">
+            <a:pPr marL="0" indent="0" algn="ctr">
               <a:lnSpc>
                 <a:spcPct val="104000"/>
               </a:lnSpc>
@@ -14506,7 +14503,7 @@
             </a:r>
           </a:p>
           <a:p>
-            <a:pPr marL="0" indent="0" algn="l">
+            <a:pPr marL="0" indent="0" algn="ctr">
               <a:lnSpc>
                 <a:spcPct val="104000"/>
               </a:lnSpc>
@@ -14527,7 +14524,7 @@
             </a:r>
           </a:p>
           <a:p>
-            <a:pPr marL="0" indent="0" algn="l">
+            <a:pPr marL="0" indent="0" algn="ctr">
               <a:lnSpc>
                 <a:spcPct val="104000"/>
               </a:lnSpc>
@@ -14548,7 +14545,7 @@
             </a:r>
           </a:p>
           <a:p>
-            <a:pPr marL="0" indent="0" algn="l">
+            <a:pPr marL="0" indent="0" algn="ctr">
               <a:lnSpc>
                 <a:spcPct val="104000"/>
               </a:lnSpc>
@@ -14569,7 +14566,7 @@
             </a:r>
           </a:p>
           <a:p>
-            <a:pPr marL="0" indent="0" algn="l">
+            <a:pPr marL="0" indent="0" algn="ctr">
               <a:lnSpc>
                 <a:spcPct val="104000"/>
               </a:lnSpc>
@@ -15008,12 +15005,12 @@
           </a:ln>
         </p:spPr>
         <p:txBody>
-          <a:bodyPr wrap="square" lIns="137160" tIns="91440" rIns="137160" bIns="91440" rtlCol="0" anchor="t">
+          <a:bodyPr wrap="square" lIns="137160" tIns="91440" rIns="137160" bIns="91440" rtlCol="0" anchor="ctr">
             <a:normAutofit/>
           </a:bodyPr>
           <a:lstStyle/>
           <a:p>
-            <a:pPr marL="0" indent="0" algn="l">
+            <a:pPr marL="0" indent="0" algn="ctr">
               <a:buNone/>
             </a:pPr>
             <a:r>
@@ -15028,15 +15025,14 @@
             </a:r>
           </a:p>
           <a:p>
-            <a:pPr marL="274320" indent="-274320" algn="l">
+            <a:pPr marL="0" indent="0" algn="ctr">
               <a:lnSpc>
                 <a:spcPct val="104000"/>
               </a:lnSpc>
               <a:spcBef>
                 <a:spcPts val="300"/>
               </a:spcBef>
-              <a:buFont typeface="Arial"/>
-              <a:buChar char="•"/>
+              <a:buNone/>
             </a:pPr>
             <a:r>
               <a:rPr lang="en-US" sz="1500" dirty="0">
@@ -15050,15 +15046,14 @@
             </a:r>
           </a:p>
           <a:p>
-            <a:pPr marL="274320" indent="-274320" algn="l">
+            <a:pPr marL="0" indent="0" algn="ctr">
               <a:lnSpc>
                 <a:spcPct val="104000"/>
               </a:lnSpc>
               <a:spcBef>
                 <a:spcPts val="300"/>
               </a:spcBef>
-              <a:buFont typeface="Arial"/>
-              <a:buChar char="•"/>
+              <a:buNone/>
             </a:pPr>
             <a:r>
               <a:rPr lang="en-US" sz="1500" dirty="0">
@@ -15542,12 +15537,12 @@
           </a:ln>
         </p:spPr>
         <p:txBody>
-          <a:bodyPr wrap="square" lIns="137160" tIns="91440" rIns="137160" bIns="91440" rtlCol="0" anchor="t">
+          <a:bodyPr wrap="square" lIns="137160" tIns="91440" rIns="137160" bIns="91440" rtlCol="0" anchor="ctr">
             <a:normAutofit/>
           </a:bodyPr>
           <a:lstStyle/>
           <a:p>
-            <a:pPr marL="0" indent="0" algn="l">
+            <a:pPr marL="0" indent="0" algn="ctr">
               <a:buNone/>
             </a:pPr>
             <a:r>
@@ -15562,15 +15557,14 @@
             </a:r>
           </a:p>
           <a:p>
-            <a:pPr marL="274320" indent="-274320" algn="l">
+            <a:pPr marL="0" indent="0" algn="ctr">
               <a:lnSpc>
                 <a:spcPct val="104000"/>
               </a:lnSpc>
               <a:spcBef>
                 <a:spcPts val="300"/>
               </a:spcBef>
-              <a:buFont typeface="Arial"/>
-              <a:buChar char="•"/>
+              <a:buNone/>
             </a:pPr>
             <a:r>
               <a:rPr lang="en-US" sz="1500" dirty="0">
@@ -15584,15 +15578,14 @@
             </a:r>
           </a:p>
           <a:p>
-            <a:pPr marL="274320" indent="-274320" algn="l">
+            <a:pPr marL="0" indent="0" algn="ctr">
               <a:lnSpc>
                 <a:spcPct val="104000"/>
               </a:lnSpc>
               <a:spcBef>
                 <a:spcPts val="300"/>
               </a:spcBef>
-              <a:buFont typeface="Arial"/>
-              <a:buChar char="•"/>
+              <a:buNone/>
             </a:pPr>
             <a:r>
               <a:rPr lang="en-US" sz="1500" dirty="0">
@@ -15606,15 +15599,14 @@
             </a:r>
           </a:p>
           <a:p>
-            <a:pPr marL="274320" indent="-274320" algn="l">
+            <a:pPr marL="0" indent="0" algn="ctr">
               <a:lnSpc>
                 <a:spcPct val="104000"/>
               </a:lnSpc>
               <a:spcBef>
                 <a:spcPts val="300"/>
               </a:spcBef>
-              <a:buFont typeface="Arial"/>
-              <a:buChar char="•"/>
+              <a:buNone/>
             </a:pPr>
             <a:r>
               <a:rPr lang="en-US" sz="1500" dirty="0">
@@ -15628,15 +15620,14 @@
             </a:r>
           </a:p>
           <a:p>
-            <a:pPr marL="274320" indent="-274320" algn="l">
+            <a:pPr marL="0" indent="0" algn="ctr">
               <a:lnSpc>
                 <a:spcPct val="104000"/>
               </a:lnSpc>
               <a:spcBef>
                 <a:spcPts val="300"/>
               </a:spcBef>
-              <a:buFont typeface="Arial"/>
-              <a:buChar char="•"/>
+              <a:buNone/>
             </a:pPr>
             <a:r>
               <a:rPr lang="en-US" sz="1500" dirty="0">
@@ -17323,12 +17314,12 @@
           </a:ln>
         </p:spPr>
         <p:txBody>
-          <a:bodyPr wrap="square" lIns="137160" tIns="91440" rIns="137160" bIns="91440" rtlCol="0" anchor="t">
+          <a:bodyPr wrap="square" lIns="137160" tIns="91440" rIns="137160" bIns="91440" rtlCol="0" anchor="ctr">
             <a:normAutofit/>
           </a:bodyPr>
           <a:lstStyle/>
           <a:p>
-            <a:pPr marL="0" indent="0" algn="l">
+            <a:pPr marL="0" indent="0" algn="ctr">
               <a:lnSpc>
                 <a:spcPct val="104000"/>
               </a:lnSpc>
@@ -17349,7 +17340,7 @@
             </a:r>
           </a:p>
           <a:p>
-            <a:pPr marL="0" indent="0" algn="l">
+            <a:pPr marL="0" indent="0" algn="ctr">
               <a:lnSpc>
                 <a:spcPct val="104000"/>
               </a:lnSpc>
@@ -17370,7 +17361,7 @@
             </a:r>
           </a:p>
           <a:p>
-            <a:pPr marL="0" indent="0" algn="l">
+            <a:pPr marL="0" indent="0" algn="ctr">
               <a:lnSpc>
                 <a:spcPct val="104000"/>
               </a:lnSpc>
@@ -17391,7 +17382,7 @@
             </a:r>
           </a:p>
           <a:p>
-            <a:pPr marL="0" indent="0" algn="l">
+            <a:pPr marL="0" indent="0" algn="ctr">
               <a:lnSpc>
                 <a:spcPct val="104000"/>
               </a:lnSpc>
@@ -17478,12 +17469,12 @@
           </a:ln>
         </p:spPr>
         <p:txBody>
-          <a:bodyPr wrap="square" lIns="137160" tIns="91440" rIns="137160" bIns="91440" rtlCol="0" anchor="t">
+          <a:bodyPr wrap="square" lIns="137160" tIns="91440" rIns="137160" bIns="91440" rtlCol="0" anchor="ctr">
             <a:normAutofit/>
           </a:bodyPr>
           <a:lstStyle/>
           <a:p>
-            <a:pPr marL="0" indent="0" algn="l">
+            <a:pPr marL="0" indent="0" algn="ctr">
               <a:lnSpc>
                 <a:spcPct val="104000"/>
               </a:lnSpc>
@@ -17504,7 +17495,7 @@
             </a:r>
           </a:p>
           <a:p>
-            <a:pPr marL="0" indent="0" algn="l">
+            <a:pPr marL="0" indent="0" algn="ctr">
               <a:lnSpc>
                 <a:spcPct val="104000"/>
               </a:lnSpc>
@@ -17525,7 +17516,7 @@
             </a:r>
           </a:p>
           <a:p>
-            <a:pPr marL="0" indent="0" algn="l">
+            <a:pPr marL="0" indent="0" algn="ctr">
               <a:lnSpc>
                 <a:spcPct val="104000"/>
               </a:lnSpc>
@@ -17546,7 +17537,7 @@
             </a:r>
           </a:p>
           <a:p>
-            <a:pPr marL="0" indent="0" algn="l">
+            <a:pPr marL="0" indent="0" algn="ctr">
               <a:lnSpc>
                 <a:spcPct val="104000"/>
               </a:lnSpc>
@@ -17567,7 +17558,7 @@
             </a:r>
           </a:p>
           <a:p>
-            <a:pPr marL="0" indent="0" algn="l">
+            <a:pPr marL="0" indent="0" algn="ctr">
               <a:lnSpc>
                 <a:spcPct val="104000"/>
               </a:lnSpc>
@@ -18258,12 +18249,12 @@
           </a:ln>
         </p:spPr>
         <p:txBody>
-          <a:bodyPr wrap="square" lIns="137160" tIns="91440" rIns="137160" bIns="91440" rtlCol="0" anchor="t">
+          <a:bodyPr wrap="square" lIns="137160" tIns="91440" rIns="137160" bIns="91440" rtlCol="0" anchor="ctr">
             <a:normAutofit/>
           </a:bodyPr>
           <a:lstStyle/>
           <a:p>
-            <a:pPr marL="0" indent="0" algn="l">
+            <a:pPr marL="0" indent="0" algn="ctr">
               <a:lnSpc>
                 <a:spcPct val="104000"/>
               </a:lnSpc>
@@ -18284,7 +18275,7 @@
             </a:r>
           </a:p>
           <a:p>
-            <a:pPr marL="0" indent="0" algn="l">
+            <a:pPr marL="0" indent="0" algn="ctr">
               <a:lnSpc>
                 <a:spcPct val="104000"/>
               </a:lnSpc>
@@ -18305,7 +18296,7 @@
             </a:r>
           </a:p>
           <a:p>
-            <a:pPr marL="0" indent="0" algn="l">
+            <a:pPr marL="0" indent="0" algn="ctr">
               <a:lnSpc>
                 <a:spcPct val="104000"/>
               </a:lnSpc>
@@ -18392,12 +18383,12 @@
           </a:ln>
         </p:spPr>
         <p:txBody>
-          <a:bodyPr wrap="square" lIns="137160" tIns="91440" rIns="137160" bIns="91440" rtlCol="0" anchor="t">
+          <a:bodyPr wrap="square" lIns="137160" tIns="91440" rIns="137160" bIns="91440" rtlCol="0" anchor="ctr">
             <a:normAutofit/>
           </a:bodyPr>
           <a:lstStyle/>
           <a:p>
-            <a:pPr marL="0" indent="0" algn="l">
+            <a:pPr marL="0" indent="0" algn="ctr">
               <a:lnSpc>
                 <a:spcPct val="104000"/>
               </a:lnSpc>
@@ -18418,7 +18409,7 @@
             </a:r>
           </a:p>
           <a:p>
-            <a:pPr marL="0" indent="0" algn="l">
+            <a:pPr marL="0" indent="0" algn="ctr">
               <a:lnSpc>
                 <a:spcPct val="104000"/>
               </a:lnSpc>
@@ -18439,7 +18430,7 @@
             </a:r>
           </a:p>
           <a:p>
-            <a:pPr marL="0" indent="0" algn="l">
+            <a:pPr marL="0" indent="0" algn="ctr">
               <a:lnSpc>
                 <a:spcPct val="104000"/>
               </a:lnSpc>
@@ -18526,12 +18517,12 @@
           </a:ln>
         </p:spPr>
         <p:txBody>
-          <a:bodyPr wrap="square" lIns="137160" tIns="91440" rIns="137160" bIns="91440" rtlCol="0" anchor="t">
+          <a:bodyPr wrap="square" lIns="137160" tIns="91440" rIns="137160" bIns="91440" rtlCol="0" anchor="ctr">
             <a:normAutofit/>
           </a:bodyPr>
           <a:lstStyle/>
           <a:p>
-            <a:pPr marL="0" indent="0" algn="l">
+            <a:pPr marL="0" indent="0" algn="ctr">
               <a:lnSpc>
                 <a:spcPct val="104000"/>
               </a:lnSpc>
@@ -18552,7 +18543,7 @@
             </a:r>
           </a:p>
           <a:p>
-            <a:pPr marL="0" indent="0" algn="l">
+            <a:pPr marL="0" indent="0" algn="ctr">
               <a:lnSpc>
                 <a:spcPct val="104000"/>
               </a:lnSpc>
@@ -18573,7 +18564,7 @@
             </a:r>
           </a:p>
           <a:p>
-            <a:pPr marL="0" indent="0" algn="l">
+            <a:pPr marL="0" indent="0" algn="ctr">
               <a:lnSpc>
                 <a:spcPct val="104000"/>
               </a:lnSpc>
@@ -18950,12 +18941,12 @@
           </a:ln>
         </p:spPr>
         <p:txBody>
-          <a:bodyPr wrap="square" lIns="137160" tIns="91440" rIns="137160" bIns="91440" rtlCol="0" anchor="t">
+          <a:bodyPr wrap="square" lIns="137160" tIns="91440" rIns="137160" bIns="91440" rtlCol="0" anchor="ctr">
             <a:normAutofit/>
           </a:bodyPr>
           <a:lstStyle/>
           <a:p>
-            <a:pPr marL="0" indent="0" algn="l">
+            <a:pPr marL="0" indent="0" algn="ctr">
               <a:lnSpc>
                 <a:spcPct val="104000"/>
               </a:lnSpc>
@@ -18976,7 +18967,7 @@
             </a:r>
           </a:p>
           <a:p>
-            <a:pPr marL="0" indent="0" algn="l">
+            <a:pPr marL="0" indent="0" algn="ctr">
               <a:lnSpc>
                 <a:spcPct val="104000"/>
               </a:lnSpc>
@@ -18997,7 +18988,7 @@
             </a:r>
           </a:p>
           <a:p>
-            <a:pPr marL="0" indent="0" algn="l">
+            <a:pPr marL="0" indent="0" algn="ctr">
               <a:lnSpc>
                 <a:spcPct val="104000"/>
               </a:lnSpc>
@@ -19084,12 +19075,12 @@
           </a:ln>
         </p:spPr>
         <p:txBody>
-          <a:bodyPr wrap="square" lIns="137160" tIns="91440" rIns="137160" bIns="91440" rtlCol="0" anchor="t">
+          <a:bodyPr wrap="square" lIns="137160" tIns="91440" rIns="137160" bIns="91440" rtlCol="0" anchor="ctr">
             <a:normAutofit/>
           </a:bodyPr>
           <a:lstStyle/>
           <a:p>
-            <a:pPr marL="0" indent="0" algn="l">
+            <a:pPr marL="0" indent="0" algn="ctr">
               <a:lnSpc>
                 <a:spcPct val="104000"/>
               </a:lnSpc>
@@ -19110,7 +19101,7 @@
             </a:r>
           </a:p>
           <a:p>
-            <a:pPr marL="0" indent="0" algn="l">
+            <a:pPr marL="0" indent="0" algn="ctr">
               <a:lnSpc>
                 <a:spcPct val="104000"/>
               </a:lnSpc>
@@ -19131,7 +19122,7 @@
             </a:r>
           </a:p>
           <a:p>
-            <a:pPr marL="0" indent="0" algn="l">
+            <a:pPr marL="0" indent="0" algn="ctr">
               <a:lnSpc>
                 <a:spcPct val="104000"/>
               </a:lnSpc>
@@ -19218,12 +19209,12 @@
           </a:ln>
         </p:spPr>
         <p:txBody>
-          <a:bodyPr wrap="square" lIns="137160" tIns="91440" rIns="137160" bIns="91440" rtlCol="0" anchor="t">
+          <a:bodyPr wrap="square" lIns="137160" tIns="91440" rIns="137160" bIns="91440" rtlCol="0" anchor="ctr">
             <a:normAutofit/>
           </a:bodyPr>
           <a:lstStyle/>
           <a:p>
-            <a:pPr marL="0" indent="0" algn="l">
+            <a:pPr marL="0" indent="0" algn="ctr">
               <a:lnSpc>
                 <a:spcPct val="104000"/>
               </a:lnSpc>
@@ -19244,7 +19235,7 @@
             </a:r>
           </a:p>
           <a:p>
-            <a:pPr marL="0" indent="0" algn="l">
+            <a:pPr marL="0" indent="0" algn="ctr">
               <a:lnSpc>
                 <a:spcPct val="104000"/>
               </a:lnSpc>
@@ -19265,7 +19256,7 @@
             </a:r>
           </a:p>
           <a:p>
-            <a:pPr marL="0" indent="0" algn="l">
+            <a:pPr marL="0" indent="0" algn="ctr">
               <a:lnSpc>
                 <a:spcPct val="104000"/>
               </a:lnSpc>
@@ -19352,12 +19343,12 @@
           </a:ln>
         </p:spPr>
         <p:txBody>
-          <a:bodyPr wrap="square" lIns="137160" tIns="91440" rIns="137160" bIns="91440" rtlCol="0" anchor="t">
+          <a:bodyPr wrap="square" lIns="137160" tIns="91440" rIns="137160" bIns="91440" rtlCol="0" anchor="ctr">
             <a:normAutofit/>
           </a:bodyPr>
           <a:lstStyle/>
           <a:p>
-            <a:pPr marL="0" indent="0" algn="l">
+            <a:pPr marL="0" indent="0" algn="ctr">
               <a:lnSpc>
                 <a:spcPct val="104000"/>
               </a:lnSpc>
@@ -19378,7 +19369,7 @@
             </a:r>
           </a:p>
           <a:p>
-            <a:pPr marL="0" indent="0" algn="l">
+            <a:pPr marL="0" indent="0" algn="ctr">
               <a:lnSpc>
                 <a:spcPct val="104000"/>
               </a:lnSpc>
@@ -19399,7 +19390,7 @@
             </a:r>
           </a:p>
           <a:p>
-            <a:pPr marL="0" indent="0" algn="l">
+            <a:pPr marL="0" indent="0" algn="ctr">
               <a:lnSpc>
                 <a:spcPct val="104000"/>
               </a:lnSpc>
@@ -20567,12 +20558,12 @@
           </a:ln>
         </p:spPr>
         <p:txBody>
-          <a:bodyPr wrap="square" lIns="137160" tIns="91440" rIns="137160" bIns="91440" rtlCol="0" anchor="t">
+          <a:bodyPr wrap="square" lIns="137160" tIns="91440" rIns="137160" bIns="91440" rtlCol="0" anchor="ctr">
             <a:normAutofit/>
           </a:bodyPr>
           <a:lstStyle/>
           <a:p>
-            <a:pPr marL="0" indent="0" algn="l">
+            <a:pPr marL="0" indent="0" algn="ctr">
               <a:buNone/>
             </a:pPr>
             <a:r>
@@ -20587,15 +20578,14 @@
             </a:r>
           </a:p>
           <a:p>
-            <a:pPr marL="274320" indent="-274320" algn="l">
+            <a:pPr marL="0" indent="0" algn="ctr">
               <a:lnSpc>
                 <a:spcPct val="104000"/>
               </a:lnSpc>
               <a:spcBef>
                 <a:spcPts val="300"/>
               </a:spcBef>
-              <a:buFont typeface="Arial"/>
-              <a:buChar char="•"/>
+              <a:buNone/>
             </a:pPr>
             <a:r>
               <a:rPr lang="en-US" sz="1500" dirty="0">
@@ -20609,15 +20599,14 @@
             </a:r>
           </a:p>
           <a:p>
-            <a:pPr marL="274320" indent="-274320" algn="l">
+            <a:pPr marL="0" indent="0" algn="ctr">
               <a:lnSpc>
                 <a:spcPct val="104000"/>
               </a:lnSpc>
               <a:spcBef>
                 <a:spcPts val="300"/>
               </a:spcBef>
-              <a:buFont typeface="Arial"/>
-              <a:buChar char="•"/>
+              <a:buNone/>
             </a:pPr>
             <a:r>
               <a:rPr lang="en-US" sz="1500" dirty="0">
@@ -20631,15 +20620,14 @@
             </a:r>
           </a:p>
           <a:p>
-            <a:pPr marL="274320" indent="-274320" algn="l">
+            <a:pPr marL="0" indent="0" algn="ctr">
               <a:lnSpc>
                 <a:spcPct val="104000"/>
               </a:lnSpc>
               <a:spcBef>
                 <a:spcPts val="300"/>
               </a:spcBef>
-              <a:buFont typeface="Arial"/>
-              <a:buChar char="•"/>
+              <a:buNone/>
             </a:pPr>
             <a:r>
               <a:rPr lang="en-US" sz="1500" dirty="0">
@@ -20653,15 +20641,14 @@
             </a:r>
           </a:p>
           <a:p>
-            <a:pPr marL="274320" indent="-274320" algn="l">
+            <a:pPr marL="0" indent="0" algn="ctr">
               <a:lnSpc>
                 <a:spcPct val="104000"/>
               </a:lnSpc>
               <a:spcBef>
                 <a:spcPts val="300"/>
               </a:spcBef>
-              <a:buFont typeface="Arial"/>
-              <a:buChar char="•"/>
+              <a:buNone/>
             </a:pPr>
             <a:r>
               <a:rPr lang="en-US" sz="1500" dirty="0">
@@ -20675,15 +20662,14 @@
             </a:r>
           </a:p>
           <a:p>
-            <a:pPr marL="274320" indent="-274320" algn="l">
+            <a:pPr marL="0" indent="0" algn="ctr">
               <a:lnSpc>
                 <a:spcPct val="104000"/>
               </a:lnSpc>
               <a:spcBef>
                 <a:spcPts val="300"/>
               </a:spcBef>
-              <a:buFont typeface="Arial"/>
-              <a:buChar char="•"/>
+              <a:buNone/>
             </a:pPr>
             <a:r>
               <a:rPr lang="en-US" sz="1500" dirty="0">
@@ -21467,12 +21453,12 @@
           </a:ln>
         </p:spPr>
         <p:txBody>
-          <a:bodyPr wrap="square" lIns="137160" tIns="91440" rIns="137160" bIns="91440" rtlCol="0" anchor="t">
+          <a:bodyPr wrap="square" lIns="137160" tIns="91440" rIns="137160" bIns="91440" rtlCol="0" anchor="ctr">
             <a:normAutofit/>
           </a:bodyPr>
           <a:lstStyle/>
           <a:p>
-            <a:pPr marL="0" indent="0" algn="l">
+            <a:pPr marL="0" indent="0" algn="ctr">
               <a:buNone/>
             </a:pPr>
             <a:r>
@@ -21487,15 +21473,14 @@
             </a:r>
           </a:p>
           <a:p>
-            <a:pPr marL="274320" indent="-274320" algn="l">
+            <a:pPr marL="0" indent="0" algn="ctr">
               <a:lnSpc>
                 <a:spcPct val="104000"/>
               </a:lnSpc>
               <a:spcBef>
                 <a:spcPts val="300"/>
               </a:spcBef>
-              <a:buFont typeface="Arial"/>
-              <a:buChar char="•"/>
+              <a:buNone/>
             </a:pPr>
             <a:r>
               <a:rPr lang="en-US" sz="1500" dirty="0">
@@ -21509,15 +21494,14 @@
             </a:r>
           </a:p>
           <a:p>
-            <a:pPr marL="274320" indent="-274320" algn="l">
+            <a:pPr marL="0" indent="0" algn="ctr">
               <a:lnSpc>
                 <a:spcPct val="104000"/>
               </a:lnSpc>
               <a:spcBef>
                 <a:spcPts val="300"/>
               </a:spcBef>
-              <a:buFont typeface="Arial"/>
-              <a:buChar char="•"/>
+              <a:buNone/>
             </a:pPr>
             <a:r>
               <a:rPr lang="en-US" sz="1500" dirty="0">
@@ -21531,15 +21515,14 @@
             </a:r>
           </a:p>
           <a:p>
-            <a:pPr marL="274320" indent="-274320" algn="l">
+            <a:pPr marL="0" indent="0" algn="ctr">
               <a:lnSpc>
                 <a:spcPct val="104000"/>
               </a:lnSpc>
               <a:spcBef>
                 <a:spcPts val="300"/>
               </a:spcBef>
-              <a:buFont typeface="Arial"/>
-              <a:buChar char="•"/>
+              <a:buNone/>
             </a:pPr>
             <a:r>
               <a:rPr lang="en-US" sz="1500" dirty="0">
@@ -21553,15 +21536,14 @@
             </a:r>
           </a:p>
           <a:p>
-            <a:pPr marL="274320" indent="-274320" algn="l">
+            <a:pPr marL="0" indent="0" algn="ctr">
               <a:lnSpc>
                 <a:spcPct val="104000"/>
               </a:lnSpc>
               <a:spcBef>
                 <a:spcPts val="300"/>
               </a:spcBef>
-              <a:buFont typeface="Arial"/>
-              <a:buChar char="•"/>
+              <a:buNone/>
             </a:pPr>
             <a:r>
               <a:rPr lang="en-US" sz="1500" dirty="0">
@@ -21575,15 +21557,14 @@
             </a:r>
           </a:p>
           <a:p>
-            <a:pPr marL="274320" indent="-274320" algn="l">
+            <a:pPr marL="0" indent="0" algn="ctr">
               <a:lnSpc>
                 <a:spcPct val="104000"/>
               </a:lnSpc>
               <a:spcBef>
                 <a:spcPts val="300"/>
               </a:spcBef>
-              <a:buFont typeface="Arial"/>
-              <a:buChar char="•"/>
+              <a:buNone/>
             </a:pPr>
             <a:r>
               <a:rPr lang="en-US" sz="1500" dirty="0">
@@ -21916,12 +21897,12 @@
           </a:ln>
         </p:spPr>
         <p:txBody>
-          <a:bodyPr wrap="square" lIns="137160" tIns="91440" rIns="137160" bIns="91440" rtlCol="0" anchor="t">
+          <a:bodyPr wrap="square" lIns="137160" tIns="91440" rIns="137160" bIns="91440" rtlCol="0" anchor="ctr">
             <a:normAutofit/>
           </a:bodyPr>
           <a:lstStyle/>
           <a:p>
-            <a:pPr marL="0" indent="0" algn="l">
+            <a:pPr marL="0" indent="0" algn="ctr">
               <a:lnSpc>
                 <a:spcPct val="104000"/>
               </a:lnSpc>
@@ -21942,7 +21923,7 @@
             </a:r>
           </a:p>
           <a:p>
-            <a:pPr marL="0" indent="0" algn="l">
+            <a:pPr marL="0" indent="0" algn="ctr">
               <a:lnSpc>
                 <a:spcPct val="104000"/>
               </a:lnSpc>
@@ -21963,7 +21944,7 @@
             </a:r>
           </a:p>
           <a:p>
-            <a:pPr marL="0" indent="0" algn="l">
+            <a:pPr marL="0" indent="0" algn="ctr">
               <a:lnSpc>
                 <a:spcPct val="104000"/>
               </a:lnSpc>
@@ -22050,12 +22031,12 @@
           </a:ln>
         </p:spPr>
         <p:txBody>
-          <a:bodyPr wrap="square" lIns="137160" tIns="91440" rIns="137160" bIns="91440" rtlCol="0" anchor="t">
+          <a:bodyPr wrap="square" lIns="137160" tIns="91440" rIns="137160" bIns="91440" rtlCol="0" anchor="ctr">
             <a:normAutofit/>
           </a:bodyPr>
           <a:lstStyle/>
           <a:p>
-            <a:pPr marL="0" indent="0" algn="l">
+            <a:pPr marL="0" indent="0" algn="ctr">
               <a:lnSpc>
                 <a:spcPct val="104000"/>
               </a:lnSpc>
@@ -22076,7 +22057,7 @@
             </a:r>
           </a:p>
           <a:p>
-            <a:pPr marL="0" indent="0" algn="l">
+            <a:pPr marL="0" indent="0" algn="ctr">
               <a:lnSpc>
                 <a:spcPct val="104000"/>
               </a:lnSpc>
@@ -22097,7 +22078,7 @@
             </a:r>
           </a:p>
           <a:p>
-            <a:pPr marL="0" indent="0" algn="l">
+            <a:pPr marL="0" indent="0" algn="ctr">
               <a:lnSpc>
                 <a:spcPct val="104000"/>
               </a:lnSpc>
@@ -22184,12 +22165,12 @@
           </a:ln>
         </p:spPr>
         <p:txBody>
-          <a:bodyPr wrap="square" lIns="137160" tIns="91440" rIns="137160" bIns="91440" rtlCol="0" anchor="t">
+          <a:bodyPr wrap="square" lIns="137160" tIns="91440" rIns="137160" bIns="91440" rtlCol="0" anchor="ctr">
             <a:normAutofit/>
           </a:bodyPr>
           <a:lstStyle/>
           <a:p>
-            <a:pPr marL="0" indent="0" algn="l">
+            <a:pPr marL="0" indent="0" algn="ctr">
               <a:lnSpc>
                 <a:spcPct val="104000"/>
               </a:lnSpc>
@@ -22210,7 +22191,7 @@
             </a:r>
           </a:p>
           <a:p>
-            <a:pPr marL="0" indent="0" algn="l">
+            <a:pPr marL="0" indent="0" algn="ctr">
               <a:lnSpc>
                 <a:spcPct val="104000"/>
               </a:lnSpc>
@@ -22231,7 +22212,7 @@
             </a:r>
           </a:p>
           <a:p>
-            <a:pPr marL="0" indent="0" algn="l">
+            <a:pPr marL="0" indent="0" algn="ctr">
               <a:lnSpc>
                 <a:spcPct val="104000"/>
               </a:lnSpc>
@@ -22591,7 +22572,7 @@
                 <a:latin typeface="Arial"/>
                 <a:cs typeface="Arial"/>
               </a:rPr>
-              <a:t>Exit question (chat or 1-question form): doctors chose restrictive fluids for some patients with septic shock and not for others. Both groups are followed to day 28. Which design? 'Caused' or 'associated'?</a:t>
+              <a:t>Exit question (in the chat): doctors chose restrictive fluids for some patients with septic shock and not for others. Both groups are followed to day 28. Which design? 'Caused' or 'associated'?</a:t>
             </a:r>
           </a:p>
           <a:p>
@@ -23272,12 +23253,12 @@
           </a:ln>
         </p:spPr>
         <p:txBody>
-          <a:bodyPr wrap="square" lIns="110000" tIns="91440" rIns="110000" bIns="91440" rtlCol="0" anchor="t">
+          <a:bodyPr wrap="square" lIns="110000" tIns="91440" rIns="110000" bIns="91440" rtlCol="0" anchor="ctr">
             <a:normAutofit/>
           </a:bodyPr>
           <a:lstStyle/>
           <a:p>
-            <a:pPr marL="0" indent="0" algn="l">
+            <a:pPr marL="0" indent="0" algn="ctr">
               <a:lnSpc>
                 <a:spcPct val="104000"/>
               </a:lnSpc>
@@ -23298,7 +23279,7 @@
             </a:r>
           </a:p>
           <a:p>
-            <a:pPr marL="0" indent="0" algn="l">
+            <a:pPr marL="0" indent="0" algn="ctr">
               <a:lnSpc>
                 <a:spcPct val="104000"/>
               </a:lnSpc>
@@ -23387,12 +23368,12 @@
           </a:ln>
         </p:spPr>
         <p:txBody>
-          <a:bodyPr wrap="square" lIns="110000" tIns="91440" rIns="110000" bIns="91440" rtlCol="0" anchor="t">
+          <a:bodyPr wrap="square" lIns="110000" tIns="91440" rIns="110000" bIns="91440" rtlCol="0" anchor="ctr">
             <a:normAutofit/>
           </a:bodyPr>
           <a:lstStyle/>
           <a:p>
-            <a:pPr marL="0" indent="0" algn="l">
+            <a:pPr marL="0" indent="0" algn="ctr">
               <a:lnSpc>
                 <a:spcPct val="104000"/>
               </a:lnSpc>
@@ -23481,12 +23462,12 @@
           </a:ln>
         </p:spPr>
         <p:txBody>
-          <a:bodyPr wrap="square" lIns="110000" tIns="91440" rIns="110000" bIns="91440" rtlCol="0" anchor="t">
+          <a:bodyPr wrap="square" lIns="110000" tIns="91440" rIns="110000" bIns="91440" rtlCol="0" anchor="ctr">
             <a:normAutofit/>
           </a:bodyPr>
           <a:lstStyle/>
           <a:p>
-            <a:pPr marL="0" indent="0" algn="l">
+            <a:pPr marL="0" indent="0" algn="ctr">
               <a:lnSpc>
                 <a:spcPct val="104000"/>
               </a:lnSpc>
@@ -23575,12 +23556,12 @@
           </a:ln>
         </p:spPr>
         <p:txBody>
-          <a:bodyPr wrap="square" lIns="110000" tIns="91440" rIns="110000" bIns="91440" rtlCol="0" anchor="t">
+          <a:bodyPr wrap="square" lIns="110000" tIns="91440" rIns="110000" bIns="91440" rtlCol="0" anchor="ctr">
             <a:normAutofit/>
           </a:bodyPr>
           <a:lstStyle/>
           <a:p>
-            <a:pPr marL="0" indent="0" algn="l">
+            <a:pPr marL="0" indent="0" algn="ctr">
               <a:lnSpc>
                 <a:spcPct val="104000"/>
               </a:lnSpc>
@@ -23669,12 +23650,12 @@
           </a:ln>
         </p:spPr>
         <p:txBody>
-          <a:bodyPr wrap="square" lIns="110000" tIns="91440" rIns="110000" bIns="91440" rtlCol="0" anchor="t">
+          <a:bodyPr wrap="square" lIns="110000" tIns="91440" rIns="110000" bIns="91440" rtlCol="0" anchor="ctr">
             <a:normAutofit/>
           </a:bodyPr>
           <a:lstStyle/>
           <a:p>
-            <a:pPr marL="0" indent="0" algn="l">
+            <a:pPr marL="0" indent="0" algn="ctr">
               <a:lnSpc>
                 <a:spcPct val="104000"/>
               </a:lnSpc>
@@ -23695,7 +23676,7 @@
             </a:r>
           </a:p>
           <a:p>
-            <a:pPr marL="0" indent="0" algn="l">
+            <a:pPr marL="0" indent="0" algn="ctr">
               <a:lnSpc>
                 <a:spcPct val="104000"/>
               </a:lnSpc>
@@ -24134,12 +24115,12 @@
           </a:ln>
         </p:spPr>
         <p:txBody>
-          <a:bodyPr wrap="square" lIns="137160" tIns="91440" rIns="137160" bIns="91440" rtlCol="0" anchor="t">
+          <a:bodyPr wrap="square" lIns="137160" tIns="91440" rIns="137160" bIns="91440" rtlCol="0" anchor="ctr">
             <a:normAutofit/>
           </a:bodyPr>
           <a:lstStyle/>
           <a:p>
-            <a:pPr marL="0" indent="0" algn="l">
+            <a:pPr marL="0" indent="0" algn="ctr">
               <a:buNone/>
             </a:pPr>
             <a:r>
@@ -24154,15 +24135,14 @@
             </a:r>
           </a:p>
           <a:p>
-            <a:pPr marL="274320" indent="-274320" algn="l">
+            <a:pPr marL="0" indent="0" algn="ctr">
               <a:lnSpc>
                 <a:spcPct val="104000"/>
               </a:lnSpc>
               <a:spcBef>
                 <a:spcPts val="300"/>
               </a:spcBef>
-              <a:buFont typeface="Arial"/>
-              <a:buChar char="•"/>
+              <a:buNone/>
             </a:pPr>
             <a:r>
               <a:rPr lang="en-US" sz="1500" dirty="0">
@@ -24176,15 +24156,14 @@
             </a:r>
           </a:p>
           <a:p>
-            <a:pPr marL="274320" indent="-274320" algn="l">
+            <a:pPr marL="0" indent="0" algn="ctr">
               <a:lnSpc>
                 <a:spcPct val="104000"/>
               </a:lnSpc>
               <a:spcBef>
                 <a:spcPts val="300"/>
               </a:spcBef>
-              <a:buFont typeface="Arial"/>
-              <a:buChar char="•"/>
+              <a:buNone/>
             </a:pPr>
             <a:r>
               <a:rPr lang="en-US" sz="1500" dirty="0">
@@ -24198,15 +24177,14 @@
             </a:r>
           </a:p>
           <a:p>
-            <a:pPr marL="274320" indent="-274320" algn="l">
+            <a:pPr marL="0" indent="0" algn="ctr">
               <a:lnSpc>
                 <a:spcPct val="104000"/>
               </a:lnSpc>
               <a:spcBef>
                 <a:spcPts val="300"/>
               </a:spcBef>
-              <a:buFont typeface="Arial"/>
-              <a:buChar char="•"/>
+              <a:buNone/>
             </a:pPr>
             <a:r>
               <a:rPr lang="en-US" sz="1500" dirty="0">
@@ -24220,15 +24198,14 @@
             </a:r>
           </a:p>
           <a:p>
-            <a:pPr marL="274320" indent="-274320" algn="l">
+            <a:pPr marL="0" indent="0" algn="ctr">
               <a:lnSpc>
                 <a:spcPct val="104000"/>
               </a:lnSpc>
               <a:spcBef>
                 <a:spcPts val="300"/>
               </a:spcBef>
-              <a:buFont typeface="Arial"/>
-              <a:buChar char="•"/>
+              <a:buNone/>
             </a:pPr>
             <a:r>
               <a:rPr lang="en-US" sz="1500" dirty="0">
@@ -24561,12 +24538,12 @@
           </a:ln>
         </p:spPr>
         <p:txBody>
-          <a:bodyPr wrap="square" lIns="137160" tIns="91440" rIns="137160" bIns="91440" rtlCol="0" anchor="t">
+          <a:bodyPr wrap="square" lIns="137160" tIns="91440" rIns="137160" bIns="91440" rtlCol="0" anchor="ctr">
             <a:normAutofit/>
           </a:bodyPr>
           <a:lstStyle/>
           <a:p>
-            <a:pPr marL="0" indent="0" algn="l">
+            <a:pPr marL="0" indent="0" algn="ctr">
               <a:lnSpc>
                 <a:spcPct val="104000"/>
               </a:lnSpc>
@@ -24587,7 +24564,7 @@
             </a:r>
           </a:p>
           <a:p>
-            <a:pPr marL="0" indent="0" algn="l">
+            <a:pPr marL="0" indent="0" algn="ctr">
               <a:lnSpc>
                 <a:spcPct val="104000"/>
               </a:lnSpc>
@@ -24608,7 +24585,7 @@
             </a:r>
           </a:p>
           <a:p>
-            <a:pPr marL="0" indent="0" algn="l">
+            <a:pPr marL="0" indent="0" algn="ctr">
               <a:lnSpc>
                 <a:spcPct val="104000"/>
               </a:lnSpc>
@@ -24695,12 +24672,12 @@
           </a:ln>
         </p:spPr>
         <p:txBody>
-          <a:bodyPr wrap="square" lIns="137160" tIns="91440" rIns="137160" bIns="91440" rtlCol="0" anchor="t">
+          <a:bodyPr wrap="square" lIns="137160" tIns="91440" rIns="137160" bIns="91440" rtlCol="0" anchor="ctr">
             <a:normAutofit/>
           </a:bodyPr>
           <a:lstStyle/>
           <a:p>
-            <a:pPr marL="0" indent="0" algn="l">
+            <a:pPr marL="0" indent="0" algn="ctr">
               <a:lnSpc>
                 <a:spcPct val="104000"/>
               </a:lnSpc>
@@ -24721,7 +24698,7 @@
             </a:r>
           </a:p>
           <a:p>
-            <a:pPr marL="0" indent="0" algn="l">
+            <a:pPr marL="0" indent="0" algn="ctr">
               <a:lnSpc>
                 <a:spcPct val="104000"/>
               </a:lnSpc>
@@ -24742,7 +24719,7 @@
             </a:r>
           </a:p>
           <a:p>
-            <a:pPr marL="0" indent="0" algn="l">
+            <a:pPr marL="0" indent="0" algn="ctr">
               <a:lnSpc>
                 <a:spcPct val="104000"/>
               </a:lnSpc>
@@ -24829,12 +24806,12 @@
           </a:ln>
         </p:spPr>
         <p:txBody>
-          <a:bodyPr wrap="square" lIns="137160" tIns="91440" rIns="137160" bIns="91440" rtlCol="0" anchor="t">
+          <a:bodyPr wrap="square" lIns="137160" tIns="91440" rIns="137160" bIns="91440" rtlCol="0" anchor="ctr">
             <a:normAutofit/>
           </a:bodyPr>
           <a:lstStyle/>
           <a:p>
-            <a:pPr marL="0" indent="0" algn="l">
+            <a:pPr marL="0" indent="0" algn="ctr">
               <a:lnSpc>
                 <a:spcPct val="104000"/>
               </a:lnSpc>
@@ -24855,7 +24832,7 @@
             </a:r>
           </a:p>
           <a:p>
-            <a:pPr marL="0" indent="0" algn="l">
+            <a:pPr marL="0" indent="0" algn="ctr">
               <a:lnSpc>
                 <a:spcPct val="104000"/>
               </a:lnSpc>
@@ -24876,7 +24853,7 @@
             </a:r>
           </a:p>
           <a:p>
-            <a:pPr marL="0" indent="0" algn="l">
+            <a:pPr marL="0" indent="0" algn="ctr">
               <a:lnSpc>
                 <a:spcPct val="104000"/>
               </a:lnSpc>
@@ -25253,12 +25230,12 @@
           </a:ln>
         </p:spPr>
         <p:txBody>
-          <a:bodyPr wrap="square" lIns="137160" tIns="91440" rIns="137160" bIns="91440" rtlCol="0" anchor="t">
+          <a:bodyPr wrap="square" lIns="137160" tIns="91440" rIns="137160" bIns="91440" rtlCol="0" anchor="ctr">
             <a:normAutofit/>
           </a:bodyPr>
           <a:lstStyle/>
           <a:p>
-            <a:pPr marL="0" indent="0" algn="l">
+            <a:pPr marL="0" indent="0" algn="ctr">
               <a:lnSpc>
                 <a:spcPct val="104000"/>
               </a:lnSpc>
@@ -25279,7 +25256,7 @@
             </a:r>
           </a:p>
           <a:p>
-            <a:pPr marL="0" indent="0" algn="l">
+            <a:pPr marL="0" indent="0" algn="ctr">
               <a:lnSpc>
                 <a:spcPct val="104000"/>
               </a:lnSpc>
@@ -25300,7 +25277,7 @@
             </a:r>
           </a:p>
           <a:p>
-            <a:pPr marL="0" indent="0" algn="l">
+            <a:pPr marL="0" indent="0" algn="ctr">
               <a:lnSpc>
                 <a:spcPct val="104000"/>
               </a:lnSpc>
@@ -25321,7 +25298,7 @@
             </a:r>
           </a:p>
           <a:p>
-            <a:pPr marL="0" indent="0" algn="l">
+            <a:pPr marL="0" indent="0" algn="ctr">
               <a:lnSpc>
                 <a:spcPct val="104000"/>
               </a:lnSpc>
@@ -25408,12 +25385,12 @@
           </a:ln>
         </p:spPr>
         <p:txBody>
-          <a:bodyPr wrap="square" lIns="137160" tIns="91440" rIns="137160" bIns="91440" rtlCol="0" anchor="t">
+          <a:bodyPr wrap="square" lIns="137160" tIns="91440" rIns="137160" bIns="91440" rtlCol="0" anchor="ctr">
             <a:normAutofit/>
           </a:bodyPr>
           <a:lstStyle/>
           <a:p>
-            <a:pPr marL="0" indent="0" algn="l">
+            <a:pPr marL="0" indent="0" algn="ctr">
               <a:lnSpc>
                 <a:spcPct val="104000"/>
               </a:lnSpc>
@@ -25434,7 +25411,7 @@
             </a:r>
           </a:p>
           <a:p>
-            <a:pPr marL="0" indent="0" algn="l">
+            <a:pPr marL="0" indent="0" algn="ctr">
               <a:lnSpc>
                 <a:spcPct val="104000"/>
               </a:lnSpc>
@@ -25455,7 +25432,7 @@
             </a:r>
           </a:p>
           <a:p>
-            <a:pPr marL="0" indent="0" algn="l">
+            <a:pPr marL="0" indent="0" algn="ctr">
               <a:lnSpc>
                 <a:spcPct val="104000"/>
               </a:lnSpc>
@@ -25476,7 +25453,7 @@
             </a:r>
           </a:p>
           <a:p>
-            <a:pPr marL="0" indent="0" algn="l">
+            <a:pPr marL="0" indent="0" algn="ctr">
               <a:lnSpc>
                 <a:spcPct val="104000"/>
               </a:lnSpc>
@@ -25915,12 +25892,12 @@
           </a:ln>
         </p:spPr>
         <p:txBody>
-          <a:bodyPr wrap="square" lIns="137160" tIns="91440" rIns="137160" bIns="91440" rtlCol="0" anchor="t">
+          <a:bodyPr wrap="square" lIns="137160" tIns="91440" rIns="137160" bIns="91440" rtlCol="0" anchor="ctr">
             <a:normAutofit/>
           </a:bodyPr>
           <a:lstStyle/>
           <a:p>
-            <a:pPr marL="0" indent="0" algn="l">
+            <a:pPr marL="0" indent="0" algn="ctr">
               <a:buNone/>
             </a:pPr>
             <a:r>
@@ -25935,15 +25912,14 @@
             </a:r>
           </a:p>
           <a:p>
-            <a:pPr marL="274320" indent="-274320" algn="l">
+            <a:pPr marL="0" indent="0" algn="ctr">
               <a:lnSpc>
                 <a:spcPct val="104000"/>
               </a:lnSpc>
               <a:spcBef>
                 <a:spcPts val="300"/>
               </a:spcBef>
-              <a:buFont typeface="Arial"/>
-              <a:buChar char="•"/>
+              <a:buNone/>
             </a:pPr>
             <a:r>
               <a:rPr lang="en-US" sz="1500" dirty="0">
@@ -25957,15 +25933,14 @@
             </a:r>
           </a:p>
           <a:p>
-            <a:pPr marL="274320" indent="-274320" algn="l">
+            <a:pPr marL="0" indent="0" algn="ctr">
               <a:lnSpc>
                 <a:spcPct val="104000"/>
               </a:lnSpc>
               <a:spcBef>
                 <a:spcPts val="300"/>
               </a:spcBef>
-              <a:buFont typeface="Arial"/>
-              <a:buChar char="•"/>
+              <a:buNone/>
             </a:pPr>
             <a:r>
               <a:rPr lang="en-US" sz="1500" dirty="0">
@@ -25979,15 +25954,14 @@
             </a:r>
           </a:p>
           <a:p>
-            <a:pPr marL="274320" indent="-274320" algn="l">
+            <a:pPr marL="0" indent="0" algn="ctr">
               <a:lnSpc>
                 <a:spcPct val="104000"/>
               </a:lnSpc>
               <a:spcBef>
                 <a:spcPts val="300"/>
               </a:spcBef>
-              <a:buFont typeface="Arial"/>
-              <a:buChar char="•"/>
+              <a:buNone/>
             </a:pPr>
             <a:r>
               <a:rPr lang="en-US" sz="1500" dirty="0">
@@ -26320,12 +26294,12 @@
           </a:ln>
         </p:spPr>
         <p:txBody>
-          <a:bodyPr wrap="square" lIns="137160" tIns="91440" rIns="137160" bIns="91440" rtlCol="0" anchor="t">
+          <a:bodyPr wrap="square" lIns="137160" tIns="91440" rIns="137160" bIns="91440" rtlCol="0" anchor="ctr">
             <a:normAutofit/>
           </a:bodyPr>
           <a:lstStyle/>
           <a:p>
-            <a:pPr marL="0" indent="0" algn="l">
+            <a:pPr marL="0" indent="0" algn="ctr">
               <a:lnSpc>
                 <a:spcPct val="104000"/>
               </a:lnSpc>
@@ -26346,7 +26320,7 @@
             </a:r>
           </a:p>
           <a:p>
-            <a:pPr marL="0" indent="0" algn="l">
+            <a:pPr marL="0" indent="0" algn="ctr">
               <a:lnSpc>
                 <a:spcPct val="104000"/>
               </a:lnSpc>
@@ -26433,12 +26407,12 @@
           </a:ln>
         </p:spPr>
         <p:txBody>
-          <a:bodyPr wrap="square" lIns="137160" tIns="91440" rIns="137160" bIns="91440" rtlCol="0" anchor="t">
+          <a:bodyPr wrap="square" lIns="137160" tIns="91440" rIns="137160" bIns="91440" rtlCol="0" anchor="ctr">
             <a:normAutofit/>
           </a:bodyPr>
           <a:lstStyle/>
           <a:p>
-            <a:pPr marL="0" indent="0" algn="l">
+            <a:pPr marL="0" indent="0" algn="ctr">
               <a:lnSpc>
                 <a:spcPct val="104000"/>
               </a:lnSpc>
@@ -26459,7 +26433,7 @@
             </a:r>
           </a:p>
           <a:p>
-            <a:pPr marL="0" indent="0" algn="l">
+            <a:pPr marL="0" indent="0" algn="ctr">
               <a:lnSpc>
                 <a:spcPct val="104000"/>
               </a:lnSpc>
@@ -26546,12 +26520,12 @@
           </a:ln>
         </p:spPr>
         <p:txBody>
-          <a:bodyPr wrap="square" lIns="137160" tIns="91440" rIns="137160" bIns="91440" rtlCol="0" anchor="t">
+          <a:bodyPr wrap="square" lIns="137160" tIns="91440" rIns="137160" bIns="91440" rtlCol="0" anchor="ctr">
             <a:normAutofit/>
           </a:bodyPr>
           <a:lstStyle/>
           <a:p>
-            <a:pPr marL="0" indent="0" algn="l">
+            <a:pPr marL="0" indent="0" algn="ctr">
               <a:lnSpc>
                 <a:spcPct val="104000"/>
               </a:lnSpc>
@@ -26572,7 +26546,7 @@
             </a:r>
           </a:p>
           <a:p>
-            <a:pPr marL="0" indent="0" algn="l">
+            <a:pPr marL="0" indent="0" algn="ctr">
               <a:lnSpc>
                 <a:spcPct val="104000"/>
               </a:lnSpc>
@@ -26949,12 +26923,12 @@
           </a:ln>
         </p:spPr>
         <p:txBody>
-          <a:bodyPr wrap="square" lIns="137160" tIns="91440" rIns="137160" bIns="91440" rtlCol="0" anchor="t">
+          <a:bodyPr wrap="square" lIns="137160" tIns="91440" rIns="137160" bIns="91440" rtlCol="0" anchor="ctr">
             <a:normAutofit/>
           </a:bodyPr>
           <a:lstStyle/>
           <a:p>
-            <a:pPr marL="0" indent="0" algn="l">
+            <a:pPr marL="0" indent="0" algn="ctr">
               <a:lnSpc>
                 <a:spcPct val="104000"/>
               </a:lnSpc>
@@ -26975,7 +26949,7 @@
             </a:r>
           </a:p>
           <a:p>
-            <a:pPr marL="0" indent="0" algn="l">
+            <a:pPr marL="0" indent="0" algn="ctr">
               <a:lnSpc>
                 <a:spcPct val="104000"/>
               </a:lnSpc>
@@ -27062,12 +27036,12 @@
           </a:ln>
         </p:spPr>
         <p:txBody>
-          <a:bodyPr wrap="square" lIns="137160" tIns="91440" rIns="137160" bIns="91440" rtlCol="0" anchor="t">
+          <a:bodyPr wrap="square" lIns="137160" tIns="91440" rIns="137160" bIns="91440" rtlCol="0" anchor="ctr">
             <a:normAutofit/>
           </a:bodyPr>
           <a:lstStyle/>
           <a:p>
-            <a:pPr marL="0" indent="0" algn="l">
+            <a:pPr marL="0" indent="0" algn="ctr">
               <a:lnSpc>
                 <a:spcPct val="104000"/>
               </a:lnSpc>
@@ -27088,7 +27062,7 @@
             </a:r>
           </a:p>
           <a:p>
-            <a:pPr marL="0" indent="0" algn="l">
+            <a:pPr marL="0" indent="0" algn="ctr">
               <a:lnSpc>
                 <a:spcPct val="104000"/>
               </a:lnSpc>
@@ -27175,12 +27149,12 @@
           </a:ln>
         </p:spPr>
         <p:txBody>
-          <a:bodyPr wrap="square" lIns="137160" tIns="91440" rIns="137160" bIns="91440" rtlCol="0" anchor="t">
+          <a:bodyPr wrap="square" lIns="137160" tIns="91440" rIns="137160" bIns="91440" rtlCol="0" anchor="ctr">
             <a:normAutofit/>
           </a:bodyPr>
           <a:lstStyle/>
           <a:p>
-            <a:pPr marL="0" indent="0" algn="l">
+            <a:pPr marL="0" indent="0" algn="ctr">
               <a:lnSpc>
                 <a:spcPct val="104000"/>
               </a:lnSpc>
@@ -27201,7 +27175,7 @@
             </a:r>
           </a:p>
           <a:p>
-            <a:pPr marL="0" indent="0" algn="l">
+            <a:pPr marL="0" indent="0" algn="ctr">
               <a:lnSpc>
                 <a:spcPct val="104000"/>
               </a:lnSpc>
@@ -27539,12 +27513,12 @@
           </a:ln>
         </p:spPr>
         <p:txBody>
-          <a:bodyPr wrap="square" lIns="137160" tIns="91440" rIns="137160" bIns="91440" rtlCol="0" anchor="t">
+          <a:bodyPr wrap="square" lIns="137160" tIns="91440" rIns="137160" bIns="91440" rtlCol="0" anchor="ctr">
             <a:normAutofit/>
           </a:bodyPr>
           <a:lstStyle/>
           <a:p>
-            <a:pPr marL="0" indent="0" algn="l">
+            <a:pPr marL="0" indent="0" algn="ctr">
               <a:lnSpc>
                 <a:spcPct val="104000"/>
               </a:lnSpc>
@@ -27565,7 +27539,7 @@
             </a:r>
           </a:p>
           <a:p>
-            <a:pPr marL="0" indent="0" algn="l">
+            <a:pPr marL="0" indent="0" algn="ctr">
               <a:lnSpc>
                 <a:spcPct val="104000"/>
               </a:lnSpc>
@@ -27652,12 +27626,12 @@
           </a:ln>
         </p:spPr>
         <p:txBody>
-          <a:bodyPr wrap="square" lIns="137160" tIns="91440" rIns="137160" bIns="91440" rtlCol="0" anchor="t">
+          <a:bodyPr wrap="square" lIns="137160" tIns="91440" rIns="137160" bIns="91440" rtlCol="0" anchor="ctr">
             <a:normAutofit/>
           </a:bodyPr>
           <a:lstStyle/>
           <a:p>
-            <a:pPr marL="0" indent="0" algn="l">
+            <a:pPr marL="0" indent="0" algn="ctr">
               <a:lnSpc>
                 <a:spcPct val="104000"/>
               </a:lnSpc>
@@ -27678,7 +27652,7 @@
             </a:r>
           </a:p>
           <a:p>
-            <a:pPr marL="0" indent="0" algn="l">
+            <a:pPr marL="0" indent="0" algn="ctr">
               <a:lnSpc>
                 <a:spcPct val="104000"/>
               </a:lnSpc>
@@ -27765,12 +27739,12 @@
           </a:ln>
         </p:spPr>
         <p:txBody>
-          <a:bodyPr wrap="square" lIns="137160" tIns="91440" rIns="137160" bIns="91440" rtlCol="0" anchor="t">
+          <a:bodyPr wrap="square" lIns="137160" tIns="91440" rIns="137160" bIns="91440" rtlCol="0" anchor="ctr">
             <a:normAutofit/>
           </a:bodyPr>
           <a:lstStyle/>
           <a:p>
-            <a:pPr marL="0" indent="0" algn="l">
+            <a:pPr marL="0" indent="0" algn="ctr">
               <a:lnSpc>
                 <a:spcPct val="104000"/>
               </a:lnSpc>
@@ -27791,7 +27765,7 @@
             </a:r>
           </a:p>
           <a:p>
-            <a:pPr marL="0" indent="0" algn="l">
+            <a:pPr marL="0" indent="0" algn="ctr">
               <a:lnSpc>
                 <a:spcPct val="104000"/>
               </a:lnSpc>
@@ -28661,12 +28635,12 @@
           </a:ln>
         </p:spPr>
         <p:txBody>
-          <a:bodyPr wrap="square" lIns="137160" tIns="91440" rIns="137160" bIns="91440" rtlCol="0" anchor="t">
+          <a:bodyPr wrap="square" lIns="137160" tIns="91440" rIns="137160" bIns="91440" rtlCol="0" anchor="ctr">
             <a:normAutofit/>
           </a:bodyPr>
           <a:lstStyle/>
           <a:p>
-            <a:pPr marL="0" indent="0" algn="l">
+            <a:pPr marL="0" indent="0" algn="ctr">
               <a:lnSpc>
                 <a:spcPct val="104000"/>
               </a:lnSpc>
@@ -28687,7 +28661,7 @@
             </a:r>
           </a:p>
           <a:p>
-            <a:pPr marL="0" indent="0" algn="l">
+            <a:pPr marL="0" indent="0" algn="ctr">
               <a:lnSpc>
                 <a:spcPct val="104000"/>
               </a:lnSpc>
@@ -28708,7 +28682,7 @@
             </a:r>
           </a:p>
           <a:p>
-            <a:pPr marL="0" indent="0" algn="l">
+            <a:pPr marL="0" indent="0" algn="ctr">
               <a:lnSpc>
                 <a:spcPct val="104000"/>
               </a:lnSpc>
@@ -28795,12 +28769,12 @@
           </a:ln>
         </p:spPr>
         <p:txBody>
-          <a:bodyPr wrap="square" lIns="137160" tIns="91440" rIns="137160" bIns="91440" rtlCol="0" anchor="t">
+          <a:bodyPr wrap="square" lIns="137160" tIns="91440" rIns="137160" bIns="91440" rtlCol="0" anchor="ctr">
             <a:normAutofit/>
           </a:bodyPr>
           <a:lstStyle/>
           <a:p>
-            <a:pPr marL="0" indent="0" algn="l">
+            <a:pPr marL="0" indent="0" algn="ctr">
               <a:lnSpc>
                 <a:spcPct val="104000"/>
               </a:lnSpc>
@@ -28821,7 +28795,7 @@
             </a:r>
           </a:p>
           <a:p>
-            <a:pPr marL="0" indent="0" algn="l">
+            <a:pPr marL="0" indent="0" algn="ctr">
               <a:lnSpc>
                 <a:spcPct val="104000"/>
               </a:lnSpc>
@@ -28842,7 +28816,7 @@
             </a:r>
           </a:p>
           <a:p>
-            <a:pPr marL="0" indent="0" algn="l">
+            <a:pPr marL="0" indent="0" algn="ctr">
               <a:lnSpc>
                 <a:spcPct val="104000"/>
               </a:lnSpc>
@@ -28929,12 +28903,12 @@
           </a:ln>
         </p:spPr>
         <p:txBody>
-          <a:bodyPr wrap="square" lIns="137160" tIns="91440" rIns="137160" bIns="91440" rtlCol="0" anchor="t">
+          <a:bodyPr wrap="square" lIns="137160" tIns="91440" rIns="137160" bIns="91440" rtlCol="0" anchor="ctr">
             <a:normAutofit/>
           </a:bodyPr>
           <a:lstStyle/>
           <a:p>
-            <a:pPr marL="0" indent="0" algn="l">
+            <a:pPr marL="0" indent="0" algn="ctr">
               <a:lnSpc>
                 <a:spcPct val="104000"/>
               </a:lnSpc>
@@ -28955,7 +28929,7 @@
             </a:r>
           </a:p>
           <a:p>
-            <a:pPr marL="0" indent="0" algn="l">
+            <a:pPr marL="0" indent="0" algn="ctr">
               <a:lnSpc>
                 <a:spcPct val="104000"/>
               </a:lnSpc>
@@ -28976,7 +28950,7 @@
             </a:r>
           </a:p>
           <a:p>
-            <a:pPr marL="0" indent="0" algn="l">
+            <a:pPr marL="0" indent="0" algn="ctr">
               <a:lnSpc>
                 <a:spcPct val="104000"/>
               </a:lnSpc>
@@ -29063,12 +29037,12 @@
           </a:ln>
         </p:spPr>
         <p:txBody>
-          <a:bodyPr wrap="square" lIns="137160" tIns="91440" rIns="137160" bIns="91440" rtlCol="0" anchor="t">
+          <a:bodyPr wrap="square" lIns="137160" tIns="91440" rIns="137160" bIns="91440" rtlCol="0" anchor="ctr">
             <a:normAutofit/>
           </a:bodyPr>
           <a:lstStyle/>
           <a:p>
-            <a:pPr marL="0" indent="0" algn="l">
+            <a:pPr marL="0" indent="0" algn="ctr">
               <a:lnSpc>
                 <a:spcPct val="104000"/>
               </a:lnSpc>
@@ -29089,7 +29063,7 @@
             </a:r>
           </a:p>
           <a:p>
-            <a:pPr marL="0" indent="0" algn="l">
+            <a:pPr marL="0" indent="0" algn="ctr">
               <a:lnSpc>
                 <a:spcPct val="104000"/>
               </a:lnSpc>
@@ -29110,7 +29084,7 @@
             </a:r>
           </a:p>
           <a:p>
-            <a:pPr marL="0" indent="0" algn="l">
+            <a:pPr marL="0" indent="0" algn="ctr">
               <a:lnSpc>
                 <a:spcPct val="104000"/>
               </a:lnSpc>
@@ -30078,12 +30052,12 @@
           </a:ln>
         </p:spPr>
         <p:txBody>
-          <a:bodyPr wrap="square" lIns="137160" tIns="91440" rIns="137160" bIns="91440" rtlCol="0" anchor="t">
+          <a:bodyPr wrap="square" lIns="137160" tIns="91440" rIns="137160" bIns="91440" rtlCol="0" anchor="ctr">
             <a:normAutofit/>
           </a:bodyPr>
           <a:lstStyle/>
           <a:p>
-            <a:pPr marL="0" indent="0" algn="l">
+            <a:pPr marL="0" indent="0" algn="ctr">
               <a:lnSpc>
                 <a:spcPct val="104000"/>
               </a:lnSpc>
@@ -30104,7 +30078,7 @@
             </a:r>
           </a:p>
           <a:p>
-            <a:pPr marL="0" indent="0" algn="l">
+            <a:pPr marL="0" indent="0" algn="ctr">
               <a:lnSpc>
                 <a:spcPct val="104000"/>
               </a:lnSpc>
@@ -30125,7 +30099,7 @@
             </a:r>
           </a:p>
           <a:p>
-            <a:pPr marL="0" indent="0" algn="l">
+            <a:pPr marL="0" indent="0" algn="ctr">
               <a:lnSpc>
                 <a:spcPct val="104000"/>
               </a:lnSpc>
@@ -30146,7 +30120,7 @@
             </a:r>
           </a:p>
           <a:p>
-            <a:pPr marL="0" indent="0" algn="l">
+            <a:pPr marL="0" indent="0" algn="ctr">
               <a:lnSpc>
                 <a:spcPct val="104000"/>
               </a:lnSpc>
@@ -30233,12 +30207,12 @@
           </a:ln>
         </p:spPr>
         <p:txBody>
-          <a:bodyPr wrap="square" lIns="137160" tIns="91440" rIns="137160" bIns="91440" rtlCol="0" anchor="t">
+          <a:bodyPr wrap="square" lIns="137160" tIns="91440" rIns="137160" bIns="91440" rtlCol="0" anchor="ctr">
             <a:normAutofit/>
           </a:bodyPr>
           <a:lstStyle/>
           <a:p>
-            <a:pPr marL="0" indent="0" algn="l">
+            <a:pPr marL="0" indent="0" algn="ctr">
               <a:lnSpc>
                 <a:spcPct val="104000"/>
               </a:lnSpc>
@@ -30259,7 +30233,7 @@
             </a:r>
           </a:p>
           <a:p>
-            <a:pPr marL="0" indent="0" algn="l">
+            <a:pPr marL="0" indent="0" algn="ctr">
               <a:lnSpc>
                 <a:spcPct val="104000"/>
               </a:lnSpc>
@@ -30280,7 +30254,7 @@
             </a:r>
           </a:p>
           <a:p>
-            <a:pPr marL="0" indent="0" algn="l">
+            <a:pPr marL="0" indent="0" algn="ctr">
               <a:lnSpc>
                 <a:spcPct val="104000"/>
               </a:lnSpc>
@@ -30301,7 +30275,7 @@
             </a:r>
           </a:p>
           <a:p>
-            <a:pPr marL="0" indent="0" algn="l">
+            <a:pPr marL="0" indent="0" algn="ctr">
               <a:lnSpc>
                 <a:spcPct val="104000"/>
               </a:lnSpc>
@@ -30680,12 +30654,12 @@
           </a:ln>
         </p:spPr>
         <p:txBody>
-          <a:bodyPr wrap="square" lIns="110000" tIns="91440" rIns="110000" bIns="91440" rtlCol="0" anchor="t">
+          <a:bodyPr wrap="square" lIns="110000" tIns="91440" rIns="110000" bIns="91440" rtlCol="0" anchor="ctr">
             <a:normAutofit/>
           </a:bodyPr>
           <a:lstStyle/>
           <a:p>
-            <a:pPr marL="0" indent="0" algn="l">
+            <a:pPr marL="0" indent="0" algn="ctr">
               <a:lnSpc>
                 <a:spcPct val="104000"/>
               </a:lnSpc>
@@ -30774,12 +30748,12 @@
           </a:ln>
         </p:spPr>
         <p:txBody>
-          <a:bodyPr wrap="square" lIns="110000" tIns="91440" rIns="110000" bIns="91440" rtlCol="0" anchor="t">
+          <a:bodyPr wrap="square" lIns="110000" tIns="91440" rIns="110000" bIns="91440" rtlCol="0" anchor="ctr">
             <a:normAutofit/>
           </a:bodyPr>
           <a:lstStyle/>
           <a:p>
-            <a:pPr marL="0" indent="0" algn="l">
+            <a:pPr marL="0" indent="0" algn="ctr">
               <a:lnSpc>
                 <a:spcPct val="104000"/>
               </a:lnSpc>
@@ -30868,12 +30842,12 @@
           </a:ln>
         </p:spPr>
         <p:txBody>
-          <a:bodyPr wrap="square" lIns="110000" tIns="91440" rIns="110000" bIns="91440" rtlCol="0" anchor="t">
+          <a:bodyPr wrap="square" lIns="110000" tIns="91440" rIns="110000" bIns="91440" rtlCol="0" anchor="ctr">
             <a:normAutofit/>
           </a:bodyPr>
           <a:lstStyle/>
           <a:p>
-            <a:pPr marL="0" indent="0" algn="l">
+            <a:pPr marL="0" indent="0" algn="ctr">
               <a:lnSpc>
                 <a:spcPct val="104000"/>
               </a:lnSpc>
@@ -30962,12 +30936,12 @@
           </a:ln>
         </p:spPr>
         <p:txBody>
-          <a:bodyPr wrap="square" lIns="110000" tIns="91440" rIns="110000" bIns="91440" rtlCol="0" anchor="t">
+          <a:bodyPr wrap="square" lIns="110000" tIns="91440" rIns="110000" bIns="91440" rtlCol="0" anchor="ctr">
             <a:normAutofit/>
           </a:bodyPr>
           <a:lstStyle/>
           <a:p>
-            <a:pPr marL="0" indent="0" algn="l">
+            <a:pPr marL="0" indent="0" algn="ctr">
               <a:lnSpc>
                 <a:spcPct val="104000"/>
               </a:lnSpc>

</xml_diff>

<commit_message>
Rebuild site: Session 3 plain-words result, Session 6 RR/OR/HR slide
</commit_message>
<xml_diff>
--- a/en/files/slides/Session_3_EN.pptx
+++ b/en/files/slides/Session_3_EN.pptx
@@ -1182,7 +1182,7 @@
           <a:p>
             <a:r>
               <a:rPr lang="en-US" sz="1400" b="0" dirty="0"/>
-              <a:t>Step 1: the cohort: who is followed (and who is left out: patients who left the ICU before day 3). Step 2: exposure measured before the outcome. Step 3: outcome counted later. Step 4: compare the groups. Hyun used propensity-score matching to make them similar (483, 373 and 392 matched pairs for days 1, 2 and 3). Day 2 result: hazard ratio (HR) 2.13 (95% confidence interval, CI, 1.48-3.06). Day 1 showed no clear difference. HR is explained properly in Session 6. For now 'about twice the rate of death'.</a:t>
+              <a:t>Step 1: the cohort: who is followed (and who is left out: patients who left the ICU before day 3). Step 2: exposure measured before the outcome. Step 3: outcome counted later. Step 4: compare the groups. Hyun used propensity-score matching to make them similar (483, 373 and 392 matched pairs for days 1, 2 and 3). Day 2 result: hazard ratio (HR) 2.13 (95% confidence interval, CI, 1.48-3.06). Day 1 showed no clear difference. Participants learned how to read a paper in Session 2 (2.3): question, design, main result. This slide applies it. The paper reports a hazard ratio (HR); on the slide we say it in plain words. Ratios come later: risk ratio and odds ratio in Session 4, HR in Session 6, with a summary slide on when each is used.</a:t>
             </a:r>
           </a:p>
           <a:p>
@@ -10167,7 +10167,7 @@
                 <a:latin typeface="Arial"/>
                 <a:cs typeface="Arial"/>
               </a:rPr>
-              <a:t>Question: is a positive fluid balance associated with death by day 28?</a:t>
+              <a:t>Read it as in Session 2. Question: is a positive fluid balance associated with death by day 28?</a:t>
             </a:r>
           </a:p>
         </p:txBody>
@@ -10543,7 +10543,7 @@
                 <a:latin typeface="Arial"/>
                 <a:cs typeface="Arial"/>
               </a:rPr>
-              <a:t>Matched pairs. Hazard ratio (HR) 2.13 for day 2</a:t>
+              <a:t>Matched pairs. On day 2, deaths about twice as frequent</a:t>
             </a:r>
           </a:p>
         </p:txBody>
@@ -14202,7 +14202,7 @@
         </p:nvSpPr>
         <p:spPr>
           <a:xfrm>
-            <a:off x="457200" y="1581816"/>
+            <a:off x="457200" y="1489211"/>
             <a:ext cx="5538800" cy="640000"/>
           </a:xfrm>
           <a:prstGeom prst="rect">
@@ -14245,8 +14245,8 @@
         </p:nvSpPr>
         <p:spPr>
           <a:xfrm>
-            <a:off x="457200" y="2221816"/>
-            <a:ext cx="5538800" cy="2304552"/>
+            <a:off x="457200" y="2129211"/>
+            <a:ext cx="5538800" cy="2582365"/>
           </a:xfrm>
           <a:prstGeom prst="rect">
             <a:avLst/>
@@ -14399,7 +14399,7 @@
         </p:nvSpPr>
         <p:spPr>
           <a:xfrm>
-            <a:off x="6196000" y="1581816"/>
+            <a:off x="6196000" y="1489211"/>
             <a:ext cx="5538800" cy="640000"/>
           </a:xfrm>
           <a:prstGeom prst="rect">
@@ -14442,8 +14442,8 @@
         </p:nvSpPr>
         <p:spPr>
           <a:xfrm>
-            <a:off x="6196000" y="2221816"/>
-            <a:ext cx="5538800" cy="2304552"/>
+            <a:off x="6196000" y="2129211"/>
+            <a:ext cx="5538800" cy="2582365"/>
           </a:xfrm>
           <a:prstGeom prst="rect">
             <a:avLst/>
@@ -14520,7 +14520,7 @@
                 <a:latin typeface="Arial"/>
                 <a:cs typeface="Arial"/>
               </a:rPr>
-              <a:t>'Associated with' (HR 2.13 on day 2)</a:t>
+              <a:t>'Associated with' (day 2: deaths about twice as frequent)</a:t>
             </a:r>
           </a:p>
           <a:p>

</xml_diff>